<commit_message>
Folien B: Join-Schlüssel im Datenmodell und Ankunftsstatus präzisiert
Co-Authored-By: Claude Opus 5.5 <noreply@anthropic.com>
Claude-Session: https://claude.ai/code/session_01M79Fp5KSK9i1dn7LtTBPHd
</commit_message>
<xml_diff>
--- a/docs/präsentation/folien_paket_b.pptx
+++ b/docs/präsentation/folien_paket_b.pptx
@@ -6592,7 +6592,7 @@
               </a:defRPr>
             </a:pPr>
             <a:r>
-              <a:t>• Status jeder Zeit (REAL, PROGNOSE, GESCHAETZT) wird mitgeführt</a:t>
+              <a:t>• Status jeder Zeit (REAL, PROGNOSE, GESCHAETZT, UNBEKANNT, leer) wird mitgeführt</a:t>
             </a:r>
           </a:p>
         </p:txBody>
@@ -8509,7 +8509,7 @@
         </p:nvSpPr>
         <p:spPr>
           <a:xfrm>
-            <a:off x="2697480" y="3154680"/>
+            <a:off x="1737360" y="3154680"/>
             <a:ext cx="2743200" cy="365760"/>
           </a:xfrm>
           <a:prstGeom prst="rect">
@@ -8535,7 +8535,7 @@
               </a:defRPr>
             </a:pPr>
             <a:r>
-              <a:t>bpuic</a:t>
+              <a:t>bpuic_haltestelle = bpuic</a:t>
             </a:r>
           </a:p>
         </p:txBody>
@@ -10398,7 +10398,7 @@
               </a:defRPr>
             </a:pPr>
             <a:r>
-              <a:t>Ankunft gemessen: Bahn 89,7 %, Bus 65,9 %, der Rest sind Prognosen oder Schätzungen. Der Status ist pro Zeit gespeichert, Paket C nimmt nur gemessene Werte.</a:t>
+              <a:t>Ankunft gemessen: Bahn 89,7 %, Bus 65,9 %. Der Rest sind Prognosen, Schätzungen oder Halte mit leerem oder unbekanntem Status (z. B. ohne Ankunft am Startort). Der Status ist pro Zeit gespeichert, Paket C nimmt nur gemessene Werte.</a:t>
             </a:r>
           </a:p>
         </p:txBody>

</xml_diff>